<commit_message>
Add CD 2017-CD3 to B-piece balances and writedown slide
Co-Authored-By: Claude Opus 5.5 <noreply@anthropic.com>
Claude-Session: https://claude.ai/code/session_01JyYo2ozkKbuwwKMUKoJFV9
</commit_message>
<xml_diff>
--- a/Historical_Conduit_CMBS_Losses.pptx
+++ b/Historical_Conduit_CMBS_Losses.pptx
@@ -688,7 +688,7 @@
             <c:idx val="7"/>
             <c:spPr>
               <a:solidFill>
-                <a:srgbClr val="005587"/>
+                <a:srgbClr val="0F2F51"/>
               </a:solidFill>
             </c:spPr>
           </c:dPt>
@@ -776,7 +776,7 @@
             <c:idx val="18"/>
             <c:spPr>
               <a:solidFill>
-                <a:srgbClr val="858D97"/>
+                <a:srgbClr val="005587"/>
               </a:solidFill>
             </c:spPr>
           </c:dPt>
@@ -828,84 +828,95 @@
               </a:solidFill>
             </c:spPr>
           </c:dPt>
+          <c:dPt>
+            <c:idx val="25"/>
+            <c:spPr>
+              <a:solidFill>
+                <a:srgbClr val="858D97"/>
+              </a:solidFill>
+            </c:spPr>
+          </c:dPt>
           <c:cat>
             <c:strRef>
-              <c:f>Sheet1!$A$2:$A$26</c:f>
+              <c:f>Sheet1!$A$2:$A$27</c:f>
               <c:strCache>
-                <c:ptCount val="25"/>
+                <c:ptCount val="26"/>
                 <c:pt idx="0">
+                  <c:v>CD 2017-CD3</c:v>
+                </c:pt>
+                <c:pt idx="1">
                   <c:v>UBSCM 2018-C12</c:v>
                 </c:pt>
-                <c:pt idx="1">
+                <c:pt idx="2">
                   <c:v>JPMDB 2017-C7</c:v>
                 </c:pt>
-                <c:pt idx="2">
+                <c:pt idx="3">
                   <c:v>UBSCM 2017-C5</c:v>
                 </c:pt>
-                <c:pt idx="3">
+                <c:pt idx="4">
                   <c:v>DBJPM 2017-C6</c:v>
                 </c:pt>
-                <c:pt idx="4">
+                <c:pt idx="5">
                   <c:v>UBSCM 2017-C3</c:v>
                 </c:pt>
-                <c:pt idx="5">
+                <c:pt idx="6">
                   <c:v>MSC 2019-H6</c:v>
                 </c:pt>
-                <c:pt idx="6">
+                <c:pt idx="7">
                   <c:v>WFCM 2019-C49</c:v>
                 </c:pt>
-                <c:pt idx="7">
+                <c:pt idx="8">
                   <c:v>UBSCM 2017-C2</c:v>
                 </c:pt>
-                <c:pt idx="8">
+                <c:pt idx="9">
                   <c:v>CGCMT 2018-C6</c:v>
                 </c:pt>
-                <c:pt idx="9">
+                <c:pt idx="10">
                   <c:v>BMARK 2018-B3</c:v>
                 </c:pt>
-                <c:pt idx="10">
+                <c:pt idx="11">
                   <c:v>UBSCM 2019-C16</c:v>
                 </c:pt>
-                <c:pt idx="11">
+                <c:pt idx="12">
                   <c:v>UBSCM 2018-C15</c:v>
                 </c:pt>
-                <c:pt idx="12">
+                <c:pt idx="13">
                   <c:v>WFCM 2018-C47</c:v>
                 </c:pt>
-                <c:pt idx="13">
+                <c:pt idx="14">
                   <c:v>BBCMS 2019-C3</c:v>
                 </c:pt>
-                <c:pt idx="14">
+                <c:pt idx="15">
                   <c:v>UBSCM 2018-C8</c:v>
                 </c:pt>
-                <c:pt idx="15">
+                <c:pt idx="16">
                   <c:v>CCUBS 2017-C1</c:v>
                 </c:pt>
-                <c:pt idx="16">
+                <c:pt idx="17">
                   <c:v>MSBAM 2017-C33</c:v>
                 </c:pt>
-                <c:pt idx="17">
+                <c:pt idx="18">
                   <c:v>UBSCM 2018-C13</c:v>
                 </c:pt>
-                <c:pt idx="18">
+                <c:pt idx="19">
                   <c:v>CGCMT 2017-C4</c:v>
                 </c:pt>
-                <c:pt idx="19">
+                <c:pt idx="20">
                   <c:v>GSMS 2017-GS8</c:v>
                 </c:pt>
-                <c:pt idx="20">
+                <c:pt idx="21">
                   <c:v>BMARK 2018-B6</c:v>
                 </c:pt>
-                <c:pt idx="21">
+                <c:pt idx="22">
                   <c:v>WFCM 2018-C43</c:v>
                 </c:pt>
-                <c:pt idx="22">
+                <c:pt idx="23">
                   <c:v>GSMS 2019-GC38</c:v>
                 </c:pt>
-                <c:pt idx="23">
+                <c:pt idx="24">
                   <c:v>GSMS 2017-GS6</c:v>
                 </c:pt>
-                <c:pt idx="24">
+                <c:pt idx="25">
                   <c:v>MSC 2018-L1</c:v>
                 </c:pt>
               </c:strCache>
@@ -913,66 +924,66 @@
           </c:cat>
           <c:val>
             <c:numRef>
-              <c:f>Sheet1!$B$2:$B$26</c:f>
+              <c:f>Sheet1!$B$2:$B$27</c:f>
               <c:numCache>
                 <c:formatCode>General</c:formatCode>
-                <c:ptCount val="25"/>
+                <c:ptCount val="26"/>
                 <c:pt idx="0">
+                  <c:v>1.0</c:v>
+                </c:pt>
+                <c:pt idx="1">
                   <c:v>0.4401689228967183</c:v>
                 </c:pt>
-                <c:pt idx="1">
+                <c:pt idx="2">
                   <c:v>0.2273606462087093</c:v>
                 </c:pt>
-                <c:pt idx="2">
+                <c:pt idx="3">
                   <c:v>0.19353300744989474</c:v>
                 </c:pt>
-                <c:pt idx="3">
+                <c:pt idx="4">
                   <c:v>0.16534524323242997</c:v>
                 </c:pt>
-                <c:pt idx="4">
+                <c:pt idx="5">
                   <c:v>0.12547495818204787</c:v>
                 </c:pt>
-                <c:pt idx="5">
+                <c:pt idx="6">
                   <c:v>0.11533489248842416</c:v>
                 </c:pt>
-                <c:pt idx="6">
+                <c:pt idx="7">
                   <c:v>0.10302661033527102</c:v>
                 </c:pt>
-                <c:pt idx="7">
+                <c:pt idx="8">
                   <c:v>0.0923454739882984</c:v>
                 </c:pt>
-                <c:pt idx="8">
+                <c:pt idx="9">
                   <c:v>0.07037364867130505</c:v>
                 </c:pt>
-                <c:pt idx="9">
+                <c:pt idx="10">
                   <c:v>0.04235948226847509</c:v>
                 </c:pt>
-                <c:pt idx="10">
+                <c:pt idx="11">
                   <c:v>0.04007460621872789</c:v>
                 </c:pt>
-                <c:pt idx="11">
+                <c:pt idx="12">
                   <c:v>0.021162764340129255</c:v>
                 </c:pt>
-                <c:pt idx="12">
+                <c:pt idx="13">
                   <c:v>0.018098623139586094</c:v>
                 </c:pt>
-                <c:pt idx="13">
+                <c:pt idx="14">
                   <c:v>0.00713544394653838</c:v>
                 </c:pt>
-                <c:pt idx="14">
+                <c:pt idx="15">
                   <c:v>0.0071169053382410105</c:v>
                 </c:pt>
-                <c:pt idx="15">
+                <c:pt idx="16">
                   <c:v>0.0063862054822237955</c:v>
                 </c:pt>
-                <c:pt idx="16">
+                <c:pt idx="17">
                   <c:v>1.850511711921599e-05</c:v>
                 </c:pt>
-                <c:pt idx="17">
+                <c:pt idx="18">
                   <c:v>1.0360755041694225e-05</c:v>
-                </c:pt>
-                <c:pt idx="18">
-                  <c:v>0.0</c:v>
                 </c:pt>
                 <c:pt idx="19">
                   <c:v>0.0</c:v>
@@ -990,6 +1001,9 @@
                   <c:v>0.0</c:v>
                 </c:pt>
                 <c:pt idx="24">
+                  <c:v>0.0</c:v>
+                </c:pt>
+                <c:pt idx="25">
                   <c:v>0.0</c:v>
                 </c:pt>
               </c:numCache>
@@ -1060,7 +1074,7 @@
       <c:valAx>
         <c:axId val="-2113994440"/>
         <c:scaling>
-          <c:max val="0.5"/>
+          <c:max val="1.18"/>
           <c:min val="0.0"/>
         </c:scaling>
         <c:delete/>
@@ -9471,7 +9485,7 @@
                 </a:solidFill>
                 <a:latin typeface="Calibri"/>
               </a:rPr>
-              <a:t>Across the 25 public deals, $130.9M of $1,944.7M of original B-piece balance (6.7%) has been written down as of the September 2026 remittance, equal to 0.61% of the $21.5B of original pool balance.</a:t>
+              <a:t>Across the 26 public deals, $241.6M of $2,055.4M of original B-piece balance (11.8%) has been written down as of the September 2026 remittance, equal to 1.06% of the $22.9B of original pool balance.</a:t>
             </a:r>
           </a:p>
           <a:p>
@@ -9499,7 +9513,7 @@
                 </a:solidFill>
                 <a:latin typeface="Calibri"/>
               </a:rPr>
-              <a:t>Losses are concentrated: UBSCM 2018-C12 (44.0%), JPMDB 2017-C7 (22.7%) and UBSCM 2017-C5 (19.4%) account for 50.6% of total writedowns, while 9 of the 25 B-pieces have no realized losses to date (less than $1,000 each).</a:t>
+              <a:t>Losses are concentrated: CD 2017-CD3 (100.0%), UBSCM 2018-C12 (44.0%) and JPMDB 2017-C7 (22.7%) account for 67.0% of total writedowns, while 9 of the 26 B-pieces have no realized losses to date (less than $1,000 each).</a:t>
             </a:r>
           </a:p>
           <a:p>
@@ -9527,7 +9541,7 @@
                 </a:solidFill>
                 <a:latin typeface="Calibri"/>
               </a:rPr>
-              <a:t>No B-piece in the group has been fully written off, and no class above the B-piece has taken a loss. Realized losses to date sit well inside the 4.4% long run conduit average, though unresolved specially serviced loans are not yet reflected.</a:t>
+              <a:t>CD 2017-CD3 is the only deal with its B-piece fully written off: Classes E, F and G ($110.7M) are at zero and Class D, the next class up, has lost $23.5M (30.7%) of its $76.5M balance. Every other B-piece remains outstanding and no other senior class has taken a loss.</a:t>
             </a:r>
           </a:p>
         </p:txBody>
@@ -9827,6 +9841,174 @@
                           </a:solidFill>
                           <a:latin typeface="Calibri"/>
                         </a:rPr>
+                        <a:t>CD 2017-CD3</a:t>
+                      </a:r>
+                    </a:p>
+                  </a:txBody>
+                  <a:tcPr marL="36576" marR="36576" marT="9144" marB="9144" anchor="ctr">
+                    <a:lnL w="0">
+                      <a:noFill/>
+                    </a:lnL>
+                    <a:lnR w="0">
+                      <a:noFill/>
+                    </a:lnR>
+                    <a:lnT w="0">
+                      <a:noFill/>
+                    </a:lnT>
+                    <a:lnB w="0">
+                      <a:noFill/>
+                    </a:lnB>
+                    <a:noFill/>
+                  </a:tcPr>
+                </a:tc>
+                <a:tc>
+                  <a:txBody>
+                    <a:bodyPr/>
+                    <a:lstStyle/>
+                    <a:p>
+                      <a:pPr marL="0" indent="0" algn="ctr">
+                        <a:spcBef>
+                          <a:spcPts val="0"/>
+                        </a:spcBef>
+                        <a:spcAft>
+                          <a:spcPts val="0"/>
+                        </a:spcAft>
+                        <a:buNone/>
+                      </a:pPr>
+                      <a:r>
+                        <a:rPr sz="800" b="0" i="0">
+                          <a:solidFill>
+                            <a:srgbClr val="080808"/>
+                          </a:solidFill>
+                          <a:latin typeface="Calibri"/>
+                        </a:rPr>
+                        <a:t>$110.7</a:t>
+                      </a:r>
+                    </a:p>
+                  </a:txBody>
+                  <a:tcPr marL="36576" marR="36576" marT="9144" marB="9144" anchor="ctr">
+                    <a:lnL w="0">
+                      <a:noFill/>
+                    </a:lnL>
+                    <a:lnR w="0">
+                      <a:noFill/>
+                    </a:lnR>
+                    <a:lnT w="0">
+                      <a:noFill/>
+                    </a:lnT>
+                    <a:lnB w="0">
+                      <a:noFill/>
+                    </a:lnB>
+                    <a:noFill/>
+                  </a:tcPr>
+                </a:tc>
+                <a:tc>
+                  <a:txBody>
+                    <a:bodyPr/>
+                    <a:lstStyle/>
+                    <a:p>
+                      <a:pPr marL="0" indent="0" algn="ctr">
+                        <a:spcBef>
+                          <a:spcPts val="0"/>
+                        </a:spcBef>
+                        <a:spcAft>
+                          <a:spcPts val="0"/>
+                        </a:spcAft>
+                        <a:buNone/>
+                      </a:pPr>
+                      <a:r>
+                        <a:rPr sz="800" b="0" i="0">
+                          <a:solidFill>
+                            <a:srgbClr val="080808"/>
+                          </a:solidFill>
+                          <a:latin typeface="Calibri"/>
+                        </a:rPr>
+                        <a:t>$110.7</a:t>
+                      </a:r>
+                    </a:p>
+                  </a:txBody>
+                  <a:tcPr marL="36576" marR="36576" marT="9144" marB="9144" anchor="ctr">
+                    <a:lnL w="0">
+                      <a:noFill/>
+                    </a:lnL>
+                    <a:lnR w="0">
+                      <a:noFill/>
+                    </a:lnR>
+                    <a:lnT w="0">
+                      <a:noFill/>
+                    </a:lnT>
+                    <a:lnB w="0">
+                      <a:noFill/>
+                    </a:lnB>
+                    <a:noFill/>
+                  </a:tcPr>
+                </a:tc>
+                <a:tc>
+                  <a:txBody>
+                    <a:bodyPr/>
+                    <a:lstStyle/>
+                    <a:p>
+                      <a:pPr marL="0" indent="0" algn="ctr">
+                        <a:spcBef>
+                          <a:spcPts val="0"/>
+                        </a:spcBef>
+                        <a:spcAft>
+                          <a:spcPts val="0"/>
+                        </a:spcAft>
+                        <a:buNone/>
+                      </a:pPr>
+                      <a:r>
+                        <a:rPr sz="800" b="0" i="0">
+                          <a:solidFill>
+                            <a:srgbClr val="080808"/>
+                          </a:solidFill>
+                          <a:latin typeface="Calibri"/>
+                        </a:rPr>
+                        <a:t>100.0%</a:t>
+                      </a:r>
+                    </a:p>
+                  </a:txBody>
+                  <a:tcPr marL="36576" marR="36576" marT="9144" marB="9144" anchor="ctr">
+                    <a:lnL w="0">
+                      <a:noFill/>
+                    </a:lnL>
+                    <a:lnR w="0">
+                      <a:noFill/>
+                    </a:lnR>
+                    <a:lnT w="0">
+                      <a:noFill/>
+                    </a:lnT>
+                    <a:lnB w="0">
+                      <a:noFill/>
+                    </a:lnB>
+                    <a:solidFill>
+                      <a:srgbClr val="F2DCDB"/>
+                    </a:solidFill>
+                  </a:tcPr>
+                </a:tc>
+              </a:tr>
+              <a:tr h="246888">
+                <a:tc>
+                  <a:txBody>
+                    <a:bodyPr/>
+                    <a:lstStyle/>
+                    <a:p>
+                      <a:pPr marL="0" indent="0" algn="l">
+                        <a:spcBef>
+                          <a:spcPts val="0"/>
+                        </a:spcBef>
+                        <a:spcAft>
+                          <a:spcPts val="0"/>
+                        </a:spcAft>
+                        <a:buNone/>
+                      </a:pPr>
+                      <a:r>
+                        <a:rPr sz="800" b="0" i="0">
+                          <a:solidFill>
+                            <a:srgbClr val="080808"/>
+                          </a:solidFill>
+                          <a:latin typeface="Calibri"/>
+                        </a:rPr>
                         <a:t>UBSCM 2018-C12</a:t>
                       </a:r>
                     </a:p>
@@ -9844,7 +10026,9 @@
                     <a:lnB w="0">
                       <a:noFill/>
                     </a:lnB>
-                    <a:noFill/>
+                    <a:solidFill>
+                      <a:srgbClr val="ECEEF0"/>
+                    </a:solidFill>
                   </a:tcPr>
                 </a:tc>
                 <a:tc>
@@ -9885,7 +10069,9 @@
                     <a:lnB w="0">
                       <a:noFill/>
                     </a:lnB>
-                    <a:noFill/>
+                    <a:solidFill>
+                      <a:srgbClr val="ECEEF0"/>
+                    </a:solidFill>
                   </a:tcPr>
                 </a:tc>
                 <a:tc>
@@ -9926,7 +10112,9 @@
                     <a:lnB w="0">
                       <a:noFill/>
                     </a:lnB>
-                    <a:noFill/>
+                    <a:solidFill>
+                      <a:srgbClr val="ECEEF0"/>
+                    </a:solidFill>
                   </a:tcPr>
                 </a:tc>
                 <a:tc>
@@ -10012,9 +10200,7 @@
                     <a:lnB w="0">
                       <a:noFill/>
                     </a:lnB>
-                    <a:solidFill>
-                      <a:srgbClr val="ECEEF0"/>
-                    </a:solidFill>
+                    <a:noFill/>
                   </a:tcPr>
                 </a:tc>
                 <a:tc>
@@ -10055,9 +10241,7 @@
                     <a:lnB w="0">
                       <a:noFill/>
                     </a:lnB>
-                    <a:solidFill>
-                      <a:srgbClr val="ECEEF0"/>
-                    </a:solidFill>
+                    <a:noFill/>
                   </a:tcPr>
                 </a:tc>
                 <a:tc>
@@ -10098,9 +10282,7 @@
                     <a:lnB w="0">
                       <a:noFill/>
                     </a:lnB>
-                    <a:solidFill>
-                      <a:srgbClr val="ECEEF0"/>
-                    </a:solidFill>
+                    <a:noFill/>
                   </a:tcPr>
                 </a:tc>
                 <a:tc>
@@ -10186,7 +10368,9 @@
                     <a:lnB w="0">
                       <a:noFill/>
                     </a:lnB>
-                    <a:noFill/>
+                    <a:solidFill>
+                      <a:srgbClr val="ECEEF0"/>
+                    </a:solidFill>
                   </a:tcPr>
                 </a:tc>
                 <a:tc>
@@ -10227,7 +10411,9 @@
                     <a:lnB w="0">
                       <a:noFill/>
                     </a:lnB>
-                    <a:noFill/>
+                    <a:solidFill>
+                      <a:srgbClr val="ECEEF0"/>
+                    </a:solidFill>
                   </a:tcPr>
                 </a:tc>
                 <a:tc>
@@ -10268,7 +10454,9 @@
                     <a:lnB w="0">
                       <a:noFill/>
                     </a:lnB>
-                    <a:noFill/>
+                    <a:solidFill>
+                      <a:srgbClr val="ECEEF0"/>
+                    </a:solidFill>
                   </a:tcPr>
                 </a:tc>
                 <a:tc>
@@ -10354,9 +10542,7 @@
                     <a:lnB w="0">
                       <a:noFill/>
                     </a:lnB>
-                    <a:solidFill>
-                      <a:srgbClr val="ECEEF0"/>
-                    </a:solidFill>
+                    <a:noFill/>
                   </a:tcPr>
                 </a:tc>
                 <a:tc>
@@ -10397,9 +10583,7 @@
                     <a:lnB w="0">
                       <a:noFill/>
                     </a:lnB>
-                    <a:solidFill>
-                      <a:srgbClr val="ECEEF0"/>
-                    </a:solidFill>
+                    <a:noFill/>
                   </a:tcPr>
                 </a:tc>
                 <a:tc>
@@ -10440,9 +10624,7 @@
                     <a:lnB w="0">
                       <a:noFill/>
                     </a:lnB>
-                    <a:solidFill>
-                      <a:srgbClr val="ECEEF0"/>
-                    </a:solidFill>
+                    <a:noFill/>
                   </a:tcPr>
                 </a:tc>
                 <a:tc>
@@ -10528,7 +10710,9 @@
                     <a:lnB w="0">
                       <a:noFill/>
                     </a:lnB>
-                    <a:noFill/>
+                    <a:solidFill>
+                      <a:srgbClr val="ECEEF0"/>
+                    </a:solidFill>
                   </a:tcPr>
                 </a:tc>
                 <a:tc>
@@ -10569,7 +10753,9 @@
                     <a:lnB w="0">
                       <a:noFill/>
                     </a:lnB>
-                    <a:noFill/>
+                    <a:solidFill>
+                      <a:srgbClr val="ECEEF0"/>
+                    </a:solidFill>
                   </a:tcPr>
                 </a:tc>
                 <a:tc>
@@ -10610,7 +10796,9 @@
                     <a:lnB w="0">
                       <a:noFill/>
                     </a:lnB>
-                    <a:noFill/>
+                    <a:solidFill>
+                      <a:srgbClr val="ECEEF0"/>
+                    </a:solidFill>
                   </a:tcPr>
                 </a:tc>
                 <a:tc>
@@ -10696,9 +10884,7 @@
                     <a:lnB w="0">
                       <a:noFill/>
                     </a:lnB>
-                    <a:solidFill>
-                      <a:srgbClr val="ECEEF0"/>
-                    </a:solidFill>
+                    <a:noFill/>
                   </a:tcPr>
                 </a:tc>
                 <a:tc>
@@ -10739,9 +10925,7 @@
                     <a:lnB w="0">
                       <a:noFill/>
                     </a:lnB>
-                    <a:solidFill>
-                      <a:srgbClr val="ECEEF0"/>
-                    </a:solidFill>
+                    <a:noFill/>
                   </a:tcPr>
                 </a:tc>
                 <a:tc>
@@ -10782,9 +10966,7 @@
                     <a:lnB w="0">
                       <a:noFill/>
                     </a:lnB>
-                    <a:solidFill>
-                      <a:srgbClr val="ECEEF0"/>
-                    </a:solidFill>
+                    <a:noFill/>
                   </a:tcPr>
                 </a:tc>
                 <a:tc>
@@ -10870,7 +11052,9 @@
                     <a:lnB w="0">
                       <a:noFill/>
                     </a:lnB>
-                    <a:noFill/>
+                    <a:solidFill>
+                      <a:srgbClr val="ECEEF0"/>
+                    </a:solidFill>
                   </a:tcPr>
                 </a:tc>
                 <a:tc>
@@ -10911,7 +11095,9 @@
                     <a:lnB w="0">
                       <a:noFill/>
                     </a:lnB>
-                    <a:noFill/>
+                    <a:solidFill>
+                      <a:srgbClr val="ECEEF0"/>
+                    </a:solidFill>
                   </a:tcPr>
                 </a:tc>
                 <a:tc>
@@ -10952,7 +11138,9 @@
                     <a:lnB w="0">
                       <a:noFill/>
                     </a:lnB>
-                    <a:noFill/>
+                    <a:solidFill>
+                      <a:srgbClr val="ECEEF0"/>
+                    </a:solidFill>
                   </a:tcPr>
                 </a:tc>
                 <a:tc>
@@ -11038,9 +11226,7 @@
                     <a:lnB w="0">
                       <a:noFill/>
                     </a:lnB>
-                    <a:solidFill>
-                      <a:srgbClr val="ECEEF0"/>
-                    </a:solidFill>
+                    <a:noFill/>
                   </a:tcPr>
                 </a:tc>
                 <a:tc>
@@ -11081,9 +11267,7 @@
                     <a:lnB w="0">
                       <a:noFill/>
                     </a:lnB>
-                    <a:solidFill>
-                      <a:srgbClr val="ECEEF0"/>
-                    </a:solidFill>
+                    <a:noFill/>
                   </a:tcPr>
                 </a:tc>
                 <a:tc>
@@ -11124,9 +11308,7 @@
                     <a:lnB w="0">
                       <a:noFill/>
                     </a:lnB>
-                    <a:solidFill>
-                      <a:srgbClr val="ECEEF0"/>
-                    </a:solidFill>
+                    <a:noFill/>
                   </a:tcPr>
                 </a:tc>
                 <a:tc>
@@ -11167,9 +11349,7 @@
                     <a:lnB w="0">
                       <a:noFill/>
                     </a:lnB>
-                    <a:solidFill>
-                      <a:srgbClr val="ECEEF0"/>
-                    </a:solidFill>
+                    <a:noFill/>
                   </a:tcPr>
                 </a:tc>
               </a:tr>
@@ -11212,7 +11392,9 @@
                     <a:lnB w="0">
                       <a:noFill/>
                     </a:lnB>
-                    <a:noFill/>
+                    <a:solidFill>
+                      <a:srgbClr val="ECEEF0"/>
+                    </a:solidFill>
                   </a:tcPr>
                 </a:tc>
                 <a:tc>
@@ -11253,7 +11435,9 @@
                     <a:lnB w="0">
                       <a:noFill/>
                     </a:lnB>
-                    <a:noFill/>
+                    <a:solidFill>
+                      <a:srgbClr val="ECEEF0"/>
+                    </a:solidFill>
                   </a:tcPr>
                 </a:tc>
                 <a:tc>
@@ -11294,7 +11478,9 @@
                     <a:lnB w="0">
                       <a:noFill/>
                     </a:lnB>
-                    <a:noFill/>
+                    <a:solidFill>
+                      <a:srgbClr val="ECEEF0"/>
+                    </a:solidFill>
                   </a:tcPr>
                 </a:tc>
                 <a:tc>
@@ -11335,178 +11521,6 @@
                     <a:lnB w="0">
                       <a:noFill/>
                     </a:lnB>
-                    <a:noFill/>
-                  </a:tcPr>
-                </a:tc>
-              </a:tr>
-              <a:tr h="246888">
-                <a:tc>
-                  <a:txBody>
-                    <a:bodyPr/>
-                    <a:lstStyle/>
-                    <a:p>
-                      <a:pPr marL="0" indent="0" algn="l">
-                        <a:spcBef>
-                          <a:spcPts val="0"/>
-                        </a:spcBef>
-                        <a:spcAft>
-                          <a:spcPts val="0"/>
-                        </a:spcAft>
-                        <a:buNone/>
-                      </a:pPr>
-                      <a:r>
-                        <a:rPr sz="800" b="0" i="0">
-                          <a:solidFill>
-                            <a:srgbClr val="080808"/>
-                          </a:solidFill>
-                          <a:latin typeface="Calibri"/>
-                        </a:rPr>
-                        <a:t>BMARK 2018-B3</a:t>
-                      </a:r>
-                    </a:p>
-                  </a:txBody>
-                  <a:tcPr marL="36576" marR="36576" marT="9144" marB="9144" anchor="ctr">
-                    <a:lnL w="0">
-                      <a:noFill/>
-                    </a:lnL>
-                    <a:lnR w="0">
-                      <a:noFill/>
-                    </a:lnR>
-                    <a:lnT w="0">
-                      <a:noFill/>
-                    </a:lnT>
-                    <a:lnB w="0">
-                      <a:noFill/>
-                    </a:lnB>
-                    <a:solidFill>
-                      <a:srgbClr val="ECEEF0"/>
-                    </a:solidFill>
-                  </a:tcPr>
-                </a:tc>
-                <a:tc>
-                  <a:txBody>
-                    <a:bodyPr/>
-                    <a:lstStyle/>
-                    <a:p>
-                      <a:pPr marL="0" indent="0" algn="ctr">
-                        <a:spcBef>
-                          <a:spcPts val="0"/>
-                        </a:spcBef>
-                        <a:spcAft>
-                          <a:spcPts val="0"/>
-                        </a:spcAft>
-                        <a:buNone/>
-                      </a:pPr>
-                      <a:r>
-                        <a:rPr sz="800" b="0" i="0">
-                          <a:solidFill>
-                            <a:srgbClr val="080808"/>
-                          </a:solidFill>
-                          <a:latin typeface="Calibri"/>
-                        </a:rPr>
-                        <a:t>$106.6</a:t>
-                      </a:r>
-                    </a:p>
-                  </a:txBody>
-                  <a:tcPr marL="36576" marR="36576" marT="9144" marB="9144" anchor="ctr">
-                    <a:lnL w="0">
-                      <a:noFill/>
-                    </a:lnL>
-                    <a:lnR w="0">
-                      <a:noFill/>
-                    </a:lnR>
-                    <a:lnT w="0">
-                      <a:noFill/>
-                    </a:lnT>
-                    <a:lnB w="0">
-                      <a:noFill/>
-                    </a:lnB>
-                    <a:solidFill>
-                      <a:srgbClr val="ECEEF0"/>
-                    </a:solidFill>
-                  </a:tcPr>
-                </a:tc>
-                <a:tc>
-                  <a:txBody>
-                    <a:bodyPr/>
-                    <a:lstStyle/>
-                    <a:p>
-                      <a:pPr marL="0" indent="0" algn="ctr">
-                        <a:spcBef>
-                          <a:spcPts val="0"/>
-                        </a:spcBef>
-                        <a:spcAft>
-                          <a:spcPts val="0"/>
-                        </a:spcAft>
-                        <a:buNone/>
-                      </a:pPr>
-                      <a:r>
-                        <a:rPr sz="800" b="0" i="0">
-                          <a:solidFill>
-                            <a:srgbClr val="080808"/>
-                          </a:solidFill>
-                          <a:latin typeface="Calibri"/>
-                        </a:rPr>
-                        <a:t>$4.5</a:t>
-                      </a:r>
-                    </a:p>
-                  </a:txBody>
-                  <a:tcPr marL="36576" marR="36576" marT="9144" marB="9144" anchor="ctr">
-                    <a:lnL w="0">
-                      <a:noFill/>
-                    </a:lnL>
-                    <a:lnR w="0">
-                      <a:noFill/>
-                    </a:lnR>
-                    <a:lnT w="0">
-                      <a:noFill/>
-                    </a:lnT>
-                    <a:lnB w="0">
-                      <a:noFill/>
-                    </a:lnB>
-                    <a:solidFill>
-                      <a:srgbClr val="ECEEF0"/>
-                    </a:solidFill>
-                  </a:tcPr>
-                </a:tc>
-                <a:tc>
-                  <a:txBody>
-                    <a:bodyPr/>
-                    <a:lstStyle/>
-                    <a:p>
-                      <a:pPr marL="0" indent="0" algn="ctr">
-                        <a:spcBef>
-                          <a:spcPts val="0"/>
-                        </a:spcBef>
-                        <a:spcAft>
-                          <a:spcPts val="0"/>
-                        </a:spcAft>
-                        <a:buNone/>
-                      </a:pPr>
-                      <a:r>
-                        <a:rPr sz="800" b="0" i="0">
-                          <a:solidFill>
-                            <a:srgbClr val="080808"/>
-                          </a:solidFill>
-                          <a:latin typeface="Calibri"/>
-                        </a:rPr>
-                        <a:t>4.2%</a:t>
-                      </a:r>
-                    </a:p>
-                  </a:txBody>
-                  <a:tcPr marL="36576" marR="36576" marT="9144" marB="9144" anchor="ctr">
-                    <a:lnL w="0">
-                      <a:noFill/>
-                    </a:lnL>
-                    <a:lnR w="0">
-                      <a:noFill/>
-                    </a:lnR>
-                    <a:lnT w="0">
-                      <a:noFill/>
-                    </a:lnT>
-                    <a:lnB w="0">
-                      <a:noFill/>
-                    </a:lnB>
                     <a:solidFill>
                       <a:srgbClr val="ECEEF0"/>
                     </a:solidFill>
@@ -11535,7 +11549,7 @@
                           </a:solidFill>
                           <a:latin typeface="Calibri"/>
                         </a:rPr>
-                        <a:t>Other 15 Deals</a:t>
+                        <a:t>Other 16 Deals</a:t>
                       </a:r>
                     </a:p>
                   </a:txBody>
@@ -11576,7 +11590,7 @@
                           </a:solidFill>
                           <a:latin typeface="Calibri"/>
                         </a:rPr>
-                        <a:t>$1,137.2</a:t>
+                        <a:t>$1,243.8</a:t>
                       </a:r>
                     </a:p>
                   </a:txBody>
@@ -11617,7 +11631,7 @@
                           </a:solidFill>
                           <a:latin typeface="Calibri"/>
                         </a:rPr>
-                        <a:t>$7.7</a:t>
+                        <a:t>$12.2</a:t>
                       </a:r>
                     </a:p>
                   </a:txBody>
@@ -11658,7 +11672,7 @@
                           </a:solidFill>
                           <a:latin typeface="Calibri"/>
                         </a:rPr>
-                        <a:t>0.7%</a:t>
+                        <a:t>1.0%</a:t>
                       </a:r>
                     </a:p>
                   </a:txBody>
@@ -11701,7 +11715,7 @@
                           </a:solidFill>
                           <a:latin typeface="Calibri"/>
                         </a:rPr>
-                        <a:t>Total (25 Deals)</a:t>
+                        <a:t>Total (26 Deals)</a:t>
                       </a:r>
                     </a:p>
                   </a:txBody>
@@ -11746,7 +11760,7 @@
                           </a:solidFill>
                           <a:latin typeface="Calibri"/>
                         </a:rPr>
-                        <a:t>$1,944.7</a:t>
+                        <a:t>$2,055.4</a:t>
                       </a:r>
                     </a:p>
                   </a:txBody>
@@ -11791,7 +11805,7 @@
                           </a:solidFill>
                           <a:latin typeface="Calibri"/>
                         </a:rPr>
-                        <a:t>$130.9</a:t>
+                        <a:t>$241.6</a:t>
                       </a:r>
                     </a:p>
                   </a:txBody>
@@ -11836,7 +11850,7 @@
                           </a:solidFill>
                           <a:latin typeface="Calibri"/>
                         </a:rPr>
-                        <a:t>6.7%</a:t>
+                        <a:t>11.8%</a:t>
                       </a:r>
                     </a:p>
                   </a:txBody>
@@ -11996,7 +12010,7 @@
                 </a:solidFill>
                 <a:latin typeface="Calibri"/>
               </a:rPr>
-              <a:t>Sources: SEC EDGAR, final prospectus (Form 424B2) for original HRR class balances and latest Form 10-D distribution report (September 2026 remittance, filed September 23 to October 2, 2026) for current balances. Writedown equals original less current HRR balance, as HRR classes receive no principal before senior classes are retired. Excludes LCCM 2017-LC26 (Rule 144A, not on EDGAR).</a:t>
+              <a:t>Sources: SEC EDGAR, final prospectus (Form 424B2) for original HRR class balances and latest Form 10-D distribution report (September 2026 remittance, filed September 22 to October 2, 2026) for current balances. Writedown equals original less current HRR balance, as HRR classes receive no principal before senior classes are retired. The CD 2017-CD3 Class D loss is excluded from B-piece totals. Excludes LCCM 2017-LC26 (Rule 144A, not on EDGAR).</a:t>
             </a:r>
           </a:p>
         </p:txBody>

</xml_diff>